<commit_message>
Add submission-ready paper variants
Add anonymised manuscripts, separate title pages and no-reference copies for both papers, and update the build script to compile paired variants. Include the guide's approval mail in the presentation and refine manuscript text.
</commit_message>
<xml_diff>
--- a/Materials/Presentation.pptx
+++ b/Materials/Presentation.pptx
@@ -3359,7 +3359,7 @@
           <a:lstStyle/>
           <a:p>
             <a:r>
-              <a:t>Replace the sample image with the guide's approval mail before the review.</a:t>
+              <a:t>The guide approved Review 3 by mail: the presentation and demonstration were approved, the report and meetings were rated satisfied, and the Turnitin similarity was 5%.</a:t>
             </a:r>
           </a:p>
         </p:txBody>
@@ -19602,7 +19602,7 @@
       </p:sp>
       <p:pic>
         <p:nvPicPr>
-          <p:cNvPr id="7" name="Picture 6" descr="Screen Shot 2026-10-05 at 11.12.42 AM.png"/>
+          <p:cNvPr id="7" name="Picture 6" descr="Approval mail from the guide for Review 3 of Project ID 18812UG01"/>
           <p:cNvPicPr>
             <a:picLocks noChangeAspect="1"/>
           </p:cNvPicPr>
@@ -19622,8 +19622,8 @@
         </p:blipFill>
         <p:spPr>
           <a:xfrm>
-            <a:off x="1624358" y="1371600"/>
-            <a:ext cx="8942979" cy="2671465"/>
+            <a:off x="1791150" y="1371600"/>
+            <a:ext cx="8609700" cy="3749040"/>
           </a:xfrm>
           <a:prstGeom prst="rect">
             <a:avLst/>

</xml_diff>